<commit_message>
chore: revisão do material do trabalho
- README: remove seção final de créditos de ferramentas
- apresentação: slide 7 passa a ser "Validação em duas máquinas" (PPTX/PDF regenerados)
- roteiro: slide 8 alinhado à validação em duas máquinas (MD/PDF regenerados)
- remove arquivo Zone.Identifier órfão
</commit_message>
<xml_diff>
--- a/apresentacao/APRESENTACAO.pptx
+++ b/apresentacao/APRESENTACAO.pptx
@@ -8717,7 +8717,7 @@
                 </a:solidFill>
                 <a:latin typeface="Calibri"/>
               </a:rPr>
-              <a:t>7. Utilização de LLM</a:t>
+              <a:t>7. Validação em duas máquinas</a:t>
             </a:r>
           </a:p>
         </p:txBody>
@@ -8756,7 +8756,7 @@
                 </a:solidFill>
                 <a:latin typeface="Calibri"/>
               </a:rPr>
-              <a:t>•  Ferramenta: Claude (Anthropic) via Claude Code CLI - auxílio ao desenvolvimento.</a:t>
+              <a:t>•  Execução em duas máquinas: Notebook x Titan (USP).</a:t>
             </a:r>
           </a:p>
           <a:p>
@@ -8772,7 +8772,7 @@
                 </a:solidFill>
                 <a:latin typeface="Calibri"/>
               </a:rPr>
-              <a:t>•  Síntese e discussão dos pseudocódigos dos slides do professor.</a:t>
+              <a:t>•  Acessos a disco IDÊNTICOS nas duas — resultado determinístico, independente do hardware.</a:t>
             </a:r>
           </a:p>
           <a:p>
@@ -8788,7 +8788,7 @@
                 </a:solidFill>
                 <a:latin typeface="Calibri"/>
               </a:rPr>
-              <a:t>•  Identificação e correção de 2 bugs: (1) stale-header em insertB; (2) eofbit do fstream.</a:t>
+              <a:t>•  Apenas o tempo de execução varia (CPU, disco e carga da máquina).</a:t>
             </a:r>
           </a:p>
           <a:p>
@@ -8804,23 +8804,7 @@
                 </a:solidFill>
                 <a:latin typeface="Calibri"/>
               </a:rPr>
-              <a:t>•  Geração do harness experimental, tabelas, gráficos e desta apresentação.</a:t>
-            </a:r>
-          </a:p>
-          <a:p>
-            <a:pPr>
-              <a:spcAft>
-                <a:spcPts val="600"/>
-              </a:spcAft>
-            </a:pPr>
-            <a:r>
-              <a:rPr sz="1400" b="0">
-                <a:solidFill>
-                  <a:srgbClr val="111827"/>
-                </a:solidFill>
-                <a:latin typeface="Calibri"/>
-              </a:rPr>
-              <a:t>•  Todo o código foi revisado e validado manualmente pelo autor.</a:t>
+              <a:t>•  Comparação automatizada via compare.py a partir dos CSVs de cada máquina.</a:t>
             </a:r>
           </a:p>
         </p:txBody>

</xml_diff>

<commit_message>
feat: comparação com array ordenado, slide das máquinas e roteiro/fala
- SortedArray em disco (busca binária O(log n); inserção/remoção O(n) por deslocamento) com itens 6 e 7 no menu para comparar com a Árvore B
- slides novos: comparação Árvore B × Array ordenado e specs das duas máquinas
- MACHINES.md: specs do servidor Titan preenchidas
- roteiro e fala da apresentação (~45 min, 38 slides)
- APRESENTACAO_2_FINAL.pptx: merge (slides 1-15 do colega + 16-38 nosso)
- slide Ferramentas: coluna substituída por Processo & reprodutibilidade
</commit_message>
<xml_diff>
--- a/apresentacao/APRESENTACAO.pptx
+++ b/apresentacao/APRESENTACAO.pptx
@@ -14033,15 +14033,10 @@
                 </a:solidFill>
                 <a:latin typeface="Calibri"/>
               </a:rPr>
-              <a:t>Claude (IA) — apoio, NÃO o autor</a:t>
-            </a:r>
-          </a:p>
-          <a:p>
-            <a:pPr>
-              <a:spcAft>
-                <a:spcPts val="500"/>
-              </a:spcAft>
-            </a:pPr>
+              <a:t>Processo &amp; reprodutibilidade</a:t>
+            </a:r>
+          </a:p>
+          <a:p>
             <a:r>
               <a:rPr sz="1250" b="0">
                 <a:solidFill>
@@ -14049,15 +14044,10 @@
                 </a:solidFill>
                 <a:latin typeface="Calibri"/>
               </a:rPr>
-              <a:t>•  Usado como assistente de apoio, revisão e incremento — a lógica da Árvore B (busca, split, remoção) é autoral.</a:t>
-            </a:r>
-          </a:p>
-          <a:p>
-            <a:pPr>
-              <a:spcAft>
-                <a:spcPts val="500"/>
-              </a:spcAft>
-            </a:pPr>
+              <a:t>•  Versionamento com Git</a:t>
+            </a:r>
+          </a:p>
+          <a:p>
             <a:r>
               <a:rPr sz="1250" b="0">
                 <a:solidFill>
@@ -14065,15 +14055,10 @@
                 </a:solidFill>
                 <a:latin typeface="Calibri"/>
               </a:rPr>
-              <a:t>•  Apoiou no desenho do MENU interativo (organização das opções e mensagens).</a:t>
-            </a:r>
-          </a:p>
-          <a:p>
-            <a:pPr>
-              <a:spcAft>
-                <a:spcPts val="500"/>
-              </a:spcAft>
-            </a:pPr>
+              <a:t>•  Experimentos reprodutíveis (CSV)</a:t>
+            </a:r>
+          </a:p>
+          <a:p>
             <a:r>
               <a:rPr sz="1250" b="0">
                 <a:solidFill>
@@ -14081,15 +14066,10 @@
                 </a:solidFill>
                 <a:latin typeface="Calibri"/>
               </a:rPr>
-              <a:t>•  Apoiou na EXPORTAÇÃO DE GRAFOS (integração com Graphviz) e nos scripts de gráficos/GIF.</a:t>
-            </a:r>
-          </a:p>
-          <a:p>
-            <a:pPr>
-              <a:spcAft>
-                <a:spcPts val="500"/>
-              </a:spcAft>
-            </a:pPr>
+              <a:t>•  Build parametrizável: make M=&lt;ordem&gt;</a:t>
+            </a:r>
+          </a:p>
+          <a:p>
             <a:r>
               <a:rPr sz="1250" b="0">
                 <a:solidFill>
@@ -14097,39 +14077,7 @@
                 </a:solidFill>
                 <a:latin typeface="Calibri"/>
               </a:rPr>
-              <a:t>•  Revisão de código e de texto: clareza dos comentários, consistência e checagem de erros.</a:t>
-            </a:r>
-          </a:p>
-          <a:p>
-            <a:pPr>
-              <a:spcAft>
-                <a:spcPts val="500"/>
-              </a:spcAft>
-            </a:pPr>
-            <a:r>
-              <a:rPr sz="1250" b="0">
-                <a:solidFill>
-                  <a:srgbClr val="111827"/>
-                </a:solidFill>
-                <a:latin typeface="Calibri"/>
-              </a:rPr>
-              <a:t>•  Incrementos de apresentação: estes slides, o roteiro e as tabelas foram gerados/revisados com apoio da IA.</a:t>
-            </a:r>
-          </a:p>
-          <a:p>
-            <a:pPr>
-              <a:spcAft>
-                <a:spcPts val="500"/>
-              </a:spcAft>
-            </a:pPr>
-            <a:r>
-              <a:rPr sz="1250" b="0">
-                <a:solidFill>
-                  <a:srgbClr val="111827"/>
-                </a:solidFill>
-                <a:latin typeface="Calibri"/>
-              </a:rPr>
-              <a:t>•  Princípio: a IA acelerou ferramentas acessórias; o entendimento e as decisões do trabalho são nossos.</a:t>
+              <a:t>•  Validação cruzada em 2 máquinas</a:t>
             </a:r>
           </a:p>
         </p:txBody>

</xml_diff>